<commit_message>
docs: finalize report with 16 references, add figures & tables, cleanup project
</commit_message>
<xml_diff>
--- a/Documentation/Mini Project PPTx.pptx
+++ b/Documentation/Mini Project PPTx.pptx
@@ -10543,11 +10543,10 @@
         </p:spPr>
         <p:txBody>
           <a:bodyPr>
-            <a:normAutofit/>
+            <a:normAutofit fontScale="85000" lnSpcReduction="20000"/>
           </a:bodyPr>
           <a:lstStyle/>
           <a:p>
-            <a:pPr algn="just"/>
             <a:r>
               <a:rPr lang="en-US" b="1" dirty="0">
                 <a:latin typeface="Times New Roman" panose="02020603050405020304" pitchFamily="18" charset="0"/>
@@ -10560,11 +10559,130 @@
                 <a:latin typeface="Times New Roman" panose="02020603050405020304" pitchFamily="18" charset="0"/>
                 <a:cs typeface="Times New Roman" panose="02020603050405020304" pitchFamily="18" charset="0"/>
               </a:rPr>
-              <a:t> Recent research proposes advanced machine learning techniques for accurate classification of Multiple Sclerosis (MS) subtypes, focusing on identifying complex clinical patterns to improve diagnostic precision.</a:t>
-            </a:r>
-          </a:p>
-          <a:p>
-            <a:pPr algn="just"/>
+              <a:t> </a:t>
+            </a:r>
+            <a:r>
+              <a:rPr lang="en-US" sz="1900" b="1" dirty="0">
+                <a:latin typeface="Times New Roman" panose="02020603050405020304" pitchFamily="18" charset="0"/>
+                <a:cs typeface="Times New Roman" panose="02020603050405020304" pitchFamily="18" charset="0"/>
+              </a:rPr>
+              <a:t>Title:</a:t>
+            </a:r>
+            <a:r>
+              <a:rPr lang="en-US" sz="1900" dirty="0">
+                <a:latin typeface="Times New Roman" panose="02020603050405020304" pitchFamily="18" charset="0"/>
+                <a:cs typeface="Times New Roman" panose="02020603050405020304" pitchFamily="18" charset="0"/>
+              </a:rPr>
+              <a:t> Machine Learning Analysis Applied to Prediction of Progression Independent of Relapse Activity (PIRA) in Multiple Sclerosis Patients</a:t>
+            </a:r>
+            <a:br>
+              <a:rPr lang="en-US" sz="1900" dirty="0">
+                <a:latin typeface="Times New Roman" panose="02020603050405020304" pitchFamily="18" charset="0"/>
+                <a:cs typeface="Times New Roman" panose="02020603050405020304" pitchFamily="18" charset="0"/>
+              </a:rPr>
+            </a:br>
+            <a:r>
+              <a:rPr lang="en-US" sz="1900" b="1" dirty="0">
+                <a:latin typeface="Times New Roman" panose="02020603050405020304" pitchFamily="18" charset="0"/>
+                <a:cs typeface="Times New Roman" panose="02020603050405020304" pitchFamily="18" charset="0"/>
+              </a:rPr>
+              <a:t>Authors:</a:t>
+            </a:r>
+            <a:r>
+              <a:rPr lang="en-US" sz="1900" dirty="0">
+                <a:latin typeface="Times New Roman" panose="02020603050405020304" pitchFamily="18" charset="0"/>
+                <a:cs typeface="Times New Roman" panose="02020603050405020304" pitchFamily="18" charset="0"/>
+              </a:rPr>
+              <a:t> </a:t>
+            </a:r>
+            <a:r>
+              <a:rPr lang="en-US" sz="1900" dirty="0" err="1">
+                <a:latin typeface="Times New Roman" panose="02020603050405020304" pitchFamily="18" charset="0"/>
+                <a:cs typeface="Times New Roman" panose="02020603050405020304" pitchFamily="18" charset="0"/>
+              </a:rPr>
+              <a:t>Poretto</a:t>
+            </a:r>
+            <a:r>
+              <a:rPr lang="en-US" sz="1900" dirty="0">
+                <a:latin typeface="Times New Roman" panose="02020603050405020304" pitchFamily="18" charset="0"/>
+                <a:cs typeface="Times New Roman" panose="02020603050405020304" pitchFamily="18" charset="0"/>
+              </a:rPr>
+              <a:t> et al.</a:t>
+            </a:r>
+            <a:br>
+              <a:rPr lang="en-US" dirty="0">
+                <a:latin typeface="Times New Roman" panose="02020603050405020304" pitchFamily="18" charset="0"/>
+                <a:cs typeface="Times New Roman" panose="02020603050405020304" pitchFamily="18" charset="0"/>
+              </a:rPr>
+            </a:br>
+            <a:r>
+              <a:rPr lang="en-US" b="1" dirty="0">
+                <a:latin typeface="Times New Roman" panose="02020603050405020304" pitchFamily="18" charset="0"/>
+                <a:cs typeface="Times New Roman" panose="02020603050405020304" pitchFamily="18" charset="0"/>
+              </a:rPr>
+              <a:t>Link:</a:t>
+            </a:r>
+            <a:r>
+              <a:rPr lang="en-US" dirty="0">
+                <a:latin typeface="Times New Roman" panose="02020603050405020304" pitchFamily="18" charset="0"/>
+                <a:cs typeface="Times New Roman" panose="02020603050405020304" pitchFamily="18" charset="0"/>
+              </a:rPr>
+              <a:t> </a:t>
+            </a:r>
+            <a:r>
+              <a:rPr lang="en-US" dirty="0">
+                <a:latin typeface="Times New Roman" panose="02020603050405020304" pitchFamily="18" charset="0"/>
+                <a:cs typeface="Times New Roman" panose="02020603050405020304" pitchFamily="18" charset="0"/>
+                <a:hlinkClick r:id="rId2"/>
+              </a:rPr>
+              <a:t>https://pmc.ncbi.nlm.nih.gov/articles/PMC12661373/</a:t>
+            </a:r>
+            <a:endParaRPr lang="en-US" dirty="0">
+              <a:latin typeface="Times New Roman" panose="02020603050405020304" pitchFamily="18" charset="0"/>
+              <a:cs typeface="Times New Roman" panose="02020603050405020304" pitchFamily="18" charset="0"/>
+            </a:endParaRPr>
+          </a:p>
+          <a:p>
+            <a:pPr marL="685800" lvl="1">
+              <a:buFont typeface="Wingdings" panose="05000000000000000000" pitchFamily="2" charset="2"/>
+              <a:buChar char="§"/>
+            </a:pPr>
+            <a:r>
+              <a:rPr lang="en-US" sz="1800" dirty="0">
+                <a:latin typeface="Times New Roman" panose="02020603050405020304" pitchFamily="18" charset="0"/>
+                <a:cs typeface="Times New Roman" panose="02020603050405020304" pitchFamily="18" charset="0"/>
+              </a:rPr>
+              <a:t>Focuses on predicting </a:t>
+            </a:r>
+            <a:r>
+              <a:rPr lang="en-US" sz="1800" b="1" dirty="0">
+                <a:latin typeface="Times New Roman" panose="02020603050405020304" pitchFamily="18" charset="0"/>
+                <a:cs typeface="Times New Roman" panose="02020603050405020304" pitchFamily="18" charset="0"/>
+              </a:rPr>
+              <a:t>PIRA (relapse-independent disability progression)</a:t>
+            </a:r>
+            <a:r>
+              <a:rPr lang="en-US" sz="1800" dirty="0">
+                <a:latin typeface="Times New Roman" panose="02020603050405020304" pitchFamily="18" charset="0"/>
+                <a:cs typeface="Times New Roman" panose="02020603050405020304" pitchFamily="18" charset="0"/>
+              </a:rPr>
+              <a:t> </a:t>
+            </a:r>
+          </a:p>
+          <a:p>
+            <a:pPr marL="685800" lvl="1">
+              <a:buFont typeface="Wingdings" panose="05000000000000000000" pitchFamily="2" charset="2"/>
+              <a:buChar char="§"/>
+            </a:pPr>
+            <a:r>
+              <a:rPr lang="en-US" sz="1800" dirty="0">
+                <a:latin typeface="Times New Roman" panose="02020603050405020304" pitchFamily="18" charset="0"/>
+                <a:cs typeface="Times New Roman" panose="02020603050405020304" pitchFamily="18" charset="0"/>
+              </a:rPr>
+              <a:t>Uses clinical and MRI-based features with ML models </a:t>
+            </a:r>
+          </a:p>
+          <a:p>
             <a:r>
               <a:rPr lang="en-US" b="1" dirty="0">
                 <a:latin typeface="Times New Roman" panose="02020603050405020304" pitchFamily="18" charset="0"/>
@@ -10577,24 +10695,113 @@
                 <a:latin typeface="Times New Roman" panose="02020603050405020304" pitchFamily="18" charset="0"/>
                 <a:cs typeface="Times New Roman" panose="02020603050405020304" pitchFamily="18" charset="0"/>
               </a:rPr>
-              <a:t> Studies highlight the application of AI models in neurological disorder prediction, emphasizing early diagnosis and data-driven clinical decision-making.</a:t>
-            </a:r>
-          </a:p>
-          <a:p>
-            <a:pPr algn="just"/>
+              <a:t> </a:t>
+            </a:r>
+            <a:r>
+              <a:rPr lang="en-US" sz="1900" b="1" dirty="0">
+                <a:latin typeface="Times New Roman" panose="02020603050405020304" pitchFamily="18" charset="0"/>
+                <a:cs typeface="Times New Roman" panose="02020603050405020304" pitchFamily="18" charset="0"/>
+              </a:rPr>
+              <a:t>Title:</a:t>
+            </a:r>
+            <a:r>
+              <a:rPr lang="en-US" sz="1900" dirty="0">
+                <a:latin typeface="Times New Roman" panose="02020603050405020304" pitchFamily="18" charset="0"/>
+                <a:cs typeface="Times New Roman" panose="02020603050405020304" pitchFamily="18" charset="0"/>
+              </a:rPr>
+              <a:t> Predictors of Short-Term, Relapse-Independent Disease Progression in Multiple Sclerosis Using Machine Learning</a:t>
+            </a:r>
+            <a:br>
+              <a:rPr lang="en-US" sz="1900" dirty="0">
+                <a:latin typeface="Times New Roman" panose="02020603050405020304" pitchFamily="18" charset="0"/>
+                <a:cs typeface="Times New Roman" panose="02020603050405020304" pitchFamily="18" charset="0"/>
+              </a:rPr>
+            </a:br>
+            <a:r>
+              <a:rPr lang="en-US" sz="1900" b="1" dirty="0">
+                <a:latin typeface="Times New Roman" panose="02020603050405020304" pitchFamily="18" charset="0"/>
+                <a:cs typeface="Times New Roman" panose="02020603050405020304" pitchFamily="18" charset="0"/>
+              </a:rPr>
+              <a:t>Authors:</a:t>
+            </a:r>
+            <a:r>
+              <a:rPr lang="en-US" sz="1900" dirty="0">
+                <a:latin typeface="Times New Roman" panose="02020603050405020304" pitchFamily="18" charset="0"/>
+                <a:cs typeface="Times New Roman" panose="02020603050405020304" pitchFamily="18" charset="0"/>
+              </a:rPr>
+              <a:t> Pérez-Miralles et al.</a:t>
+            </a:r>
+            <a:br>
+              <a:rPr lang="en-US" dirty="0">
+                <a:latin typeface="Times New Roman" panose="02020603050405020304" pitchFamily="18" charset="0"/>
+                <a:cs typeface="Times New Roman" panose="02020603050405020304" pitchFamily="18" charset="0"/>
+              </a:rPr>
+            </a:br>
             <a:r>
               <a:rPr lang="en-US" b="1" dirty="0">
                 <a:latin typeface="Times New Roman" panose="02020603050405020304" pitchFamily="18" charset="0"/>
                 <a:cs typeface="Times New Roman" panose="02020603050405020304" pitchFamily="18" charset="0"/>
               </a:rPr>
-              <a:t>(2024)</a:t>
+              <a:t>Link:</a:t>
             </a:r>
             <a:r>
               <a:rPr lang="en-US" dirty="0">
                 <a:latin typeface="Times New Roman" panose="02020603050405020304" pitchFamily="18" charset="0"/>
                 <a:cs typeface="Times New Roman" panose="02020603050405020304" pitchFamily="18" charset="0"/>
               </a:rPr>
-              <a:t> Deep learning-based approaches have been explored for MS subtype classification, addressing challenges such as model accuracy, interpretability, and clinical reliability.</a:t>
+              <a:t> </a:t>
+            </a:r>
+            <a:r>
+              <a:rPr lang="en-US" dirty="0">
+                <a:latin typeface="Times New Roman" panose="02020603050405020304" pitchFamily="18" charset="0"/>
+                <a:cs typeface="Times New Roman" panose="02020603050405020304" pitchFamily="18" charset="0"/>
+                <a:hlinkClick r:id="rId3"/>
+              </a:rPr>
+              <a:t>https://www.sciencedirect.com/science/article/pii/S0022510X26001280</a:t>
+            </a:r>
+            <a:endParaRPr lang="en-US" dirty="0">
+              <a:latin typeface="Times New Roman" panose="02020603050405020304" pitchFamily="18" charset="0"/>
+              <a:cs typeface="Times New Roman" panose="02020603050405020304" pitchFamily="18" charset="0"/>
+            </a:endParaRPr>
+          </a:p>
+          <a:p>
+            <a:pPr lvl="1">
+              <a:buFont typeface="Wingdings" panose="05000000000000000000" pitchFamily="2" charset="2"/>
+              <a:buChar char="§"/>
+            </a:pPr>
+            <a:r>
+              <a:rPr lang="en-US" sz="1800" dirty="0">
+                <a:latin typeface="Times New Roman" panose="02020603050405020304" pitchFamily="18" charset="0"/>
+                <a:cs typeface="Times New Roman" panose="02020603050405020304" pitchFamily="18" charset="0"/>
+              </a:rPr>
+              <a:t>Predicts short-term </a:t>
+            </a:r>
+            <a:r>
+              <a:rPr lang="en-US" sz="1800" b="1" dirty="0">
+                <a:latin typeface="Times New Roman" panose="02020603050405020304" pitchFamily="18" charset="0"/>
+                <a:cs typeface="Times New Roman" panose="02020603050405020304" pitchFamily="18" charset="0"/>
+              </a:rPr>
+              <a:t>PIRA risk (24–36 months)</a:t>
+            </a:r>
+            <a:r>
+              <a:rPr lang="en-US" sz="1800" dirty="0">
+                <a:latin typeface="Times New Roman" panose="02020603050405020304" pitchFamily="18" charset="0"/>
+                <a:cs typeface="Times New Roman" panose="02020603050405020304" pitchFamily="18" charset="0"/>
+              </a:rPr>
+              <a:t> </a:t>
+            </a:r>
+          </a:p>
+          <a:p>
+            <a:pPr lvl="1">
+              <a:buFont typeface="Wingdings" panose="05000000000000000000" pitchFamily="2" charset="2"/>
+              <a:buChar char="§"/>
+            </a:pPr>
+            <a:r>
+              <a:rPr lang="en-US" sz="1800" dirty="0">
+                <a:latin typeface="Times New Roman" panose="02020603050405020304" pitchFamily="18" charset="0"/>
+                <a:cs typeface="Times New Roman" panose="02020603050405020304" pitchFamily="18" charset="0"/>
+              </a:rPr>
+              <a:t>Uses clinical + MRI features</a:t>
             </a:r>
           </a:p>
           <a:p>
@@ -10666,7 +10873,7 @@
           <p:nvPr/>
         </p:nvPicPr>
         <p:blipFill>
-          <a:blip r:embed="rId2">
+          <a:blip r:embed="rId4">
             <a:extLst>
               <a:ext uri="{28A0092B-C50C-407E-A947-70E740481C1C}">
                 <a14:useLocalDpi xmlns:a14="http://schemas.microsoft.com/office/drawing/2010/main" val="0"/>

</xml_diff>